<commit_message>
v3 - Explore Tab and User Profile implemented
</commit_message>
<xml_diff>
--- a/NotesHub-Draft-1.pptx
+++ b/NotesHub-Draft-1.pptx
@@ -17,10 +17,8 @@
     <p:sldId id="277" r:id="rId11"/>
     <p:sldId id="278" r:id="rId12"/>
     <p:sldId id="279" r:id="rId13"/>
-    <p:sldId id="280" r:id="rId14"/>
-    <p:sldId id="281" r:id="rId15"/>
-    <p:sldId id="282" r:id="rId16"/>
-    <p:sldId id="270" r:id="rId17"/>
+    <p:sldId id="282" r:id="rId14"/>
+    <p:sldId id="270" r:id="rId15"/>
   </p:sldIdLst>
   <p:sldSz cx="18288000" cy="10287000"/>
   <p:notesSz cx="18288000" cy="10287000"/>
@@ -201,7 +199,7 @@
           <a:p>
             <a:fld id="{1D8BD707-D9CF-40AE-B4C6-C98DA3205C09}" type="datetimeFigureOut">
               <a:rPr lang="en-US"/>
-              <a:t>2/27/2026</a:t>
+              <a:t>4/10/2026</a:t>
             </a:fld>
             <a:endParaRPr lang="en-US"/>
           </a:p>
@@ -372,7 +370,7 @@
           <a:p>
             <a:fld id="{1D8BD707-D9CF-40AE-B4C6-C98DA3205C09}" type="datetimeFigureOut">
               <a:rPr lang="en-US"/>
-              <a:t>2/27/2026</a:t>
+              <a:t>4/10/2026</a:t>
             </a:fld>
             <a:endParaRPr lang="en-US"/>
           </a:p>
@@ -2351,7 +2349,7 @@
           <a:p>
             <a:fld id="{1D8BD707-D9CF-40AE-B4C6-C98DA3205C09}" type="datetimeFigureOut">
               <a:rPr lang="en-US"/>
-              <a:t>2/27/2026</a:t>
+              <a:t>4/10/2026</a:t>
             </a:fld>
             <a:endParaRPr lang="en-US"/>
           </a:p>
@@ -2499,7 +2497,7 @@
           <a:p>
             <a:fld id="{1D8BD707-D9CF-40AE-B4C6-C98DA3205C09}" type="datetimeFigureOut">
               <a:rPr lang="en-US"/>
-              <a:t>2/27/2026</a:t>
+              <a:t>4/10/2026</a:t>
             </a:fld>
             <a:endParaRPr lang="en-US"/>
           </a:p>
@@ -2626,7 +2624,7 @@
           <a:p>
             <a:fld id="{1D8BD707-D9CF-40AE-B4C6-C98DA3205C09}" type="datetimeFigureOut">
               <a:rPr lang="en-US"/>
-              <a:t>2/27/2026</a:t>
+              <a:t>4/10/2026</a:t>
             </a:fld>
             <a:endParaRPr lang="en-US"/>
           </a:p>
@@ -2867,7 +2865,7 @@
           <a:p>
             <a:fld id="{1D8BD707-D9CF-40AE-B4C6-C98DA3205C09}" type="datetimeFigureOut">
               <a:rPr lang="en-US"/>
-              <a:t>2/27/2026</a:t>
+              <a:t>4/10/2026</a:t>
             </a:fld>
             <a:endParaRPr lang="en-US"/>
           </a:p>
@@ -5551,727 +5549,6 @@
         <p:cNvPr id="1" name="">
           <a:extLst>
             <a:ext uri="{FF2B5EF4-FFF2-40B4-BE49-F238E27FC236}">
-              <a16:creationId xmlns:a16="http://schemas.microsoft.com/office/drawing/2014/main" id="{1B26A695-3921-64BD-F166-40552E29B122}"/>
-            </a:ext>
-          </a:extLst>
-        </p:cNvPr>
-        <p:cNvGrpSpPr/>
-        <p:nvPr/>
-      </p:nvGrpSpPr>
-      <p:grpSpPr>
-        <a:xfrm>
-          <a:off x="0" y="0"/>
-          <a:ext cx="0" cy="0"/>
-          <a:chOff x="0" y="0"/>
-          <a:chExt cx="0" cy="0"/>
-        </a:xfrm>
-      </p:grpSpPr>
-      <p:sp>
-        <p:nvSpPr>
-          <p:cNvPr id="7" name="object 7">
-            <a:extLst>
-              <a:ext uri="{FF2B5EF4-FFF2-40B4-BE49-F238E27FC236}">
-                <a16:creationId xmlns:a16="http://schemas.microsoft.com/office/drawing/2014/main" id="{5B9AA0AD-327B-824B-8F52-5213BAE99DC9}"/>
-              </a:ext>
-            </a:extLst>
-          </p:cNvPr>
-          <p:cNvSpPr txBox="1">
-            <a:spLocks noGrp="1"/>
-          </p:cNvSpPr>
-          <p:nvPr>
-            <p:ph type="title"/>
-          </p:nvPr>
-        </p:nvSpPr>
-        <p:spPr>
-          <a:xfrm>
-            <a:off x="1016020" y="986508"/>
-            <a:ext cx="16255959" cy="561692"/>
-          </a:xfrm>
-          <a:prstGeom prst="rect">
-            <a:avLst/>
-          </a:prstGeom>
-        </p:spPr>
-        <p:txBody>
-          <a:bodyPr vert="horz" wrap="square" lIns="0" tIns="15875" rIns="0" bIns="0" rtlCol="0">
-            <a:spAutoFit/>
-          </a:bodyPr>
-          <a:lstStyle/>
-          <a:p>
-            <a:pPr marL="12700">
-              <a:lnSpc>
-                <a:spcPts val="4105"/>
-              </a:lnSpc>
-              <a:spcBef>
-                <a:spcPts val="125"/>
-              </a:spcBef>
-            </a:pPr>
-            <a:r>
-              <a:rPr lang="en-US" sz="3600" b="0" u="heavy" spc="-25" dirty="0">
-                <a:solidFill>
-                  <a:srgbClr val="000000"/>
-                </a:solidFill>
-                <a:uFill>
-                  <a:solidFill>
-                    <a:srgbClr val="000000"/>
-                  </a:solidFill>
-                </a:uFill>
-                <a:latin typeface="Lucida Sans Unicode"/>
-                <a:cs typeface="Lucida Sans Unicode"/>
-              </a:rPr>
-              <a:t>What’s Done?</a:t>
-            </a:r>
-            <a:endParaRPr sz="4300" dirty="0"/>
-          </a:p>
-        </p:txBody>
-      </p:sp>
-      <p:sp>
-        <p:nvSpPr>
-          <p:cNvPr id="8" name="object 8">
-            <a:extLst>
-              <a:ext uri="{FF2B5EF4-FFF2-40B4-BE49-F238E27FC236}">
-                <a16:creationId xmlns:a16="http://schemas.microsoft.com/office/drawing/2014/main" id="{4ADFF295-DEB5-488C-2F8C-486E4DAE3821}"/>
-              </a:ext>
-            </a:extLst>
-          </p:cNvPr>
-          <p:cNvSpPr txBox="1"/>
-          <p:nvPr/>
-        </p:nvSpPr>
-        <p:spPr>
-          <a:xfrm>
-            <a:off x="1021882" y="1790700"/>
-            <a:ext cx="9569918" cy="5627053"/>
-          </a:xfrm>
-          <a:prstGeom prst="rect">
-            <a:avLst/>
-          </a:prstGeom>
-        </p:spPr>
-        <p:txBody>
-          <a:bodyPr vert="horz" wrap="square" lIns="0" tIns="12700" rIns="0" bIns="0" rtlCol="0">
-            <a:spAutoFit/>
-          </a:bodyPr>
-          <a:lstStyle/>
-          <a:p>
-            <a:pPr marL="12700" marR="5080">
-              <a:lnSpc>
-                <a:spcPct val="113599"/>
-              </a:lnSpc>
-              <a:spcBef>
-                <a:spcPts val="100"/>
-              </a:spcBef>
-            </a:pPr>
-            <a:r>
-              <a:rPr lang="en-US" sz="2400" dirty="0">
-                <a:latin typeface="Lucida Sans Unicode"/>
-                <a:cs typeface="Lucida Sans Unicode"/>
-              </a:rPr>
-              <a:t>We have implemented Backend, in which we have implemented the following end points: </a:t>
-            </a:r>
-          </a:p>
-          <a:p>
-            <a:pPr marL="355600" marR="5080" indent="-342900">
-              <a:lnSpc>
-                <a:spcPct val="113599"/>
-              </a:lnSpc>
-              <a:spcBef>
-                <a:spcPts val="100"/>
-              </a:spcBef>
-              <a:buFont typeface="Wingdings" panose="05000000000000000000" pitchFamily="2" charset="2"/>
-              <a:buChar char="§"/>
-            </a:pPr>
-            <a:r>
-              <a:rPr lang="en-US" sz="2400" dirty="0">
-                <a:latin typeface="Lucida Sans Unicode"/>
-                <a:cs typeface="Lucida Sans Unicode"/>
-              </a:rPr>
-              <a:t>/users : to create users</a:t>
-            </a:r>
-          </a:p>
-          <a:p>
-            <a:pPr marL="355600" marR="5080" indent="-342900">
-              <a:lnSpc>
-                <a:spcPct val="113599"/>
-              </a:lnSpc>
-              <a:spcBef>
-                <a:spcPts val="100"/>
-              </a:spcBef>
-              <a:buFont typeface="Wingdings" panose="05000000000000000000" pitchFamily="2" charset="2"/>
-              <a:buChar char="§"/>
-            </a:pPr>
-            <a:r>
-              <a:rPr lang="en-US" sz="2400" dirty="0">
-                <a:latin typeface="Lucida Sans Unicode"/>
-                <a:cs typeface="Lucida Sans Unicode"/>
-              </a:rPr>
-              <a:t>/subject-notes : To create a subject</a:t>
-            </a:r>
-          </a:p>
-          <a:p>
-            <a:pPr marL="355600" marR="5080" indent="-342900">
-              <a:lnSpc>
-                <a:spcPct val="113599"/>
-              </a:lnSpc>
-              <a:spcBef>
-                <a:spcPts val="100"/>
-              </a:spcBef>
-              <a:buFont typeface="Wingdings" panose="05000000000000000000" pitchFamily="2" charset="2"/>
-              <a:buChar char="§"/>
-            </a:pPr>
-            <a:r>
-              <a:rPr lang="en-US" sz="2400" dirty="0">
-                <a:latin typeface="Lucida Sans Unicode"/>
-                <a:cs typeface="Lucida Sans Unicode"/>
-              </a:rPr>
-              <a:t>/notes : to create a note inside a subject</a:t>
-            </a:r>
-          </a:p>
-          <a:p>
-            <a:pPr marL="355600" marR="5080" indent="-342900">
-              <a:lnSpc>
-                <a:spcPct val="113599"/>
-              </a:lnSpc>
-              <a:spcBef>
-                <a:spcPts val="100"/>
-              </a:spcBef>
-              <a:buFont typeface="Wingdings" panose="05000000000000000000" pitchFamily="2" charset="2"/>
-              <a:buChar char="§"/>
-            </a:pPr>
-            <a:r>
-              <a:rPr lang="en-US" sz="2400" dirty="0">
-                <a:latin typeface="Lucida Sans Unicode"/>
-                <a:cs typeface="Lucida Sans Unicode"/>
-              </a:rPr>
-              <a:t>/versions : to save a version</a:t>
-            </a:r>
-          </a:p>
-          <a:p>
-            <a:pPr marL="355600" marR="5080" indent="-342900">
-              <a:lnSpc>
-                <a:spcPct val="113599"/>
-              </a:lnSpc>
-              <a:spcBef>
-                <a:spcPts val="100"/>
-              </a:spcBef>
-              <a:buFont typeface="Wingdings" panose="05000000000000000000" pitchFamily="2" charset="2"/>
-              <a:buChar char="§"/>
-            </a:pPr>
-            <a:endParaRPr lang="en-US" sz="2400" dirty="0">
-              <a:latin typeface="Lucida Sans Unicode"/>
-              <a:cs typeface="Lucida Sans Unicode"/>
-            </a:endParaRPr>
-          </a:p>
-          <a:p>
-            <a:pPr marL="12700" marR="5080">
-              <a:lnSpc>
-                <a:spcPct val="113599"/>
-              </a:lnSpc>
-              <a:spcBef>
-                <a:spcPts val="100"/>
-              </a:spcBef>
-            </a:pPr>
-            <a:r>
-              <a:rPr lang="en-US" sz="2400" dirty="0">
-                <a:latin typeface="Lucida Sans Unicode"/>
-                <a:cs typeface="Lucida Sans Unicode"/>
-              </a:rPr>
-              <a:t>Frontend:</a:t>
-            </a:r>
-          </a:p>
-          <a:p>
-            <a:pPr marL="355600" marR="5080" indent="-342900">
-              <a:lnSpc>
-                <a:spcPct val="113599"/>
-              </a:lnSpc>
-              <a:spcBef>
-                <a:spcPts val="100"/>
-              </a:spcBef>
-              <a:buFont typeface="Wingdings" panose="05000000000000000000" pitchFamily="2" charset="2"/>
-              <a:buChar char="§"/>
-            </a:pPr>
-            <a:r>
-              <a:rPr lang="en-US" sz="2400" dirty="0" err="1">
-                <a:latin typeface="Lucida Sans Unicode"/>
-                <a:cs typeface="Lucida Sans Unicode"/>
-              </a:rPr>
-              <a:t>NoteEditor</a:t>
-            </a:r>
-            <a:endParaRPr lang="en-US" sz="2400" dirty="0">
-              <a:latin typeface="Lucida Sans Unicode"/>
-              <a:cs typeface="Lucida Sans Unicode"/>
-            </a:endParaRPr>
-          </a:p>
-          <a:p>
-            <a:pPr marL="355600" marR="5080" indent="-342900">
-              <a:lnSpc>
-                <a:spcPct val="113599"/>
-              </a:lnSpc>
-              <a:spcBef>
-                <a:spcPts val="100"/>
-              </a:spcBef>
-              <a:buFont typeface="Wingdings" panose="05000000000000000000" pitchFamily="2" charset="2"/>
-              <a:buChar char="§"/>
-            </a:pPr>
-            <a:r>
-              <a:rPr lang="en-US" sz="2400" dirty="0">
-                <a:latin typeface="Lucida Sans Unicode"/>
-                <a:cs typeface="Lucida Sans Unicode"/>
-              </a:rPr>
-              <a:t>Dashboard</a:t>
-            </a:r>
-          </a:p>
-          <a:p>
-            <a:pPr marL="355600" marR="5080" indent="-342900">
-              <a:lnSpc>
-                <a:spcPct val="113599"/>
-              </a:lnSpc>
-              <a:spcBef>
-                <a:spcPts val="100"/>
-              </a:spcBef>
-              <a:buFont typeface="Wingdings" panose="05000000000000000000" pitchFamily="2" charset="2"/>
-              <a:buChar char="§"/>
-            </a:pPr>
-            <a:r>
-              <a:rPr lang="en-US" sz="2400" dirty="0">
-                <a:latin typeface="Lucida Sans Unicode"/>
-                <a:cs typeface="Lucida Sans Unicode"/>
-              </a:rPr>
-              <a:t>Signup/Login</a:t>
-            </a:r>
-          </a:p>
-          <a:p>
-            <a:pPr marL="355600" marR="5080" indent="-342900">
-              <a:lnSpc>
-                <a:spcPct val="113599"/>
-              </a:lnSpc>
-              <a:spcBef>
-                <a:spcPts val="100"/>
-              </a:spcBef>
-              <a:buFont typeface="Wingdings" panose="05000000000000000000" pitchFamily="2" charset="2"/>
-              <a:buChar char="§"/>
-            </a:pPr>
-            <a:endParaRPr lang="en-US" sz="2400" dirty="0">
-              <a:latin typeface="Lucida Sans Unicode"/>
-              <a:cs typeface="Lucida Sans Unicode"/>
-            </a:endParaRPr>
-          </a:p>
-          <a:p>
-            <a:pPr marL="12700" marR="5080">
-              <a:lnSpc>
-                <a:spcPct val="113599"/>
-              </a:lnSpc>
-              <a:spcBef>
-                <a:spcPts val="100"/>
-              </a:spcBef>
-            </a:pPr>
-            <a:r>
-              <a:rPr lang="en-US" sz="2400" dirty="0" err="1">
-                <a:latin typeface="Lucida Sans Unicode"/>
-                <a:cs typeface="Lucida Sans Unicode"/>
-              </a:rPr>
-              <a:t>Datebase</a:t>
-            </a:r>
-            <a:r>
-              <a:rPr lang="en-US" sz="2400" dirty="0">
-                <a:latin typeface="Lucida Sans Unicode"/>
-                <a:cs typeface="Lucida Sans Unicode"/>
-              </a:rPr>
-              <a:t> design</a:t>
-            </a:r>
-          </a:p>
-        </p:txBody>
-      </p:sp>
-      <p:sp>
-        <p:nvSpPr>
-          <p:cNvPr id="9" name="object 2">
-            <a:extLst>
-              <a:ext uri="{FF2B5EF4-FFF2-40B4-BE49-F238E27FC236}">
-                <a16:creationId xmlns:a16="http://schemas.microsoft.com/office/drawing/2014/main" id="{02098EAE-8F90-6A64-EB14-852641CFB662}"/>
-              </a:ext>
-            </a:extLst>
-          </p:cNvPr>
-          <p:cNvSpPr/>
-          <p:nvPr/>
-        </p:nvSpPr>
-        <p:spPr>
-          <a:xfrm>
-            <a:off x="15201900" y="0"/>
-            <a:ext cx="3086100" cy="10283190"/>
-          </a:xfrm>
-          <a:custGeom>
-            <a:avLst/>
-            <a:gdLst/>
-            <a:ahLst/>
-            <a:cxnLst/>
-            <a:rect l="l" t="t" r="r" b="b"/>
-            <a:pathLst>
-              <a:path w="3086100" h="10283190">
-                <a:moveTo>
-                  <a:pt x="3086099" y="10282980"/>
-                </a:moveTo>
-                <a:lnTo>
-                  <a:pt x="0" y="10282980"/>
-                </a:lnTo>
-                <a:lnTo>
-                  <a:pt x="0" y="0"/>
-                </a:lnTo>
-                <a:lnTo>
-                  <a:pt x="3086099" y="0"/>
-                </a:lnTo>
-                <a:lnTo>
-                  <a:pt x="3086099" y="10282980"/>
-                </a:lnTo>
-                <a:close/>
-              </a:path>
-            </a:pathLst>
-          </a:custGeom>
-          <a:solidFill>
-            <a:srgbClr val="583C8F"/>
-          </a:solidFill>
-        </p:spPr>
-        <p:txBody>
-          <a:bodyPr wrap="square" lIns="0" tIns="0" rIns="0" bIns="0" rtlCol="0"/>
-          <a:lstStyle/>
-          <a:p>
-            <a:endParaRPr/>
-          </a:p>
-        </p:txBody>
-      </p:sp>
-      <p:sp>
-        <p:nvSpPr>
-          <p:cNvPr id="2" name="object 7">
-            <a:extLst>
-              <a:ext uri="{FF2B5EF4-FFF2-40B4-BE49-F238E27FC236}">
-                <a16:creationId xmlns:a16="http://schemas.microsoft.com/office/drawing/2014/main" id="{C7640657-15A3-211B-3F68-022E2AAB2380}"/>
-              </a:ext>
-            </a:extLst>
-          </p:cNvPr>
-          <p:cNvSpPr txBox="1">
-            <a:spLocks/>
-          </p:cNvSpPr>
-          <p:nvPr/>
-        </p:nvSpPr>
-        <p:spPr>
-          <a:xfrm>
-            <a:off x="1027743" y="6316992"/>
-            <a:ext cx="16255959" cy="561692"/>
-          </a:xfrm>
-          <a:prstGeom prst="rect">
-            <a:avLst/>
-          </a:prstGeom>
-        </p:spPr>
-        <p:txBody>
-          <a:bodyPr vert="horz" wrap="square" lIns="0" tIns="15875" rIns="0" bIns="0" rtlCol="0">
-            <a:spAutoFit/>
-          </a:bodyPr>
-          <a:lstStyle>
-            <a:lvl1pPr>
-              <a:defRPr sz="4750" b="1" i="0">
-                <a:solidFill>
-                  <a:srgbClr val="583C8F"/>
-                </a:solidFill>
-                <a:latin typeface="Trebuchet MS"/>
-                <a:ea typeface="+mj-ea"/>
-                <a:cs typeface="Trebuchet MS"/>
-              </a:defRPr>
-            </a:lvl1pPr>
-          </a:lstStyle>
-          <a:p>
-            <a:pPr marL="12700">
-              <a:lnSpc>
-                <a:spcPts val="4105"/>
-              </a:lnSpc>
-              <a:spcBef>
-                <a:spcPts val="125"/>
-              </a:spcBef>
-            </a:pPr>
-            <a:r>
-              <a:rPr lang="en-US" sz="4300" u="heavy" spc="495" dirty="0">
-                <a:uFill>
-                  <a:solidFill>
-                    <a:srgbClr val="000000"/>
-                  </a:solidFill>
-                </a:uFill>
-              </a:rPr>
-              <a:t> </a:t>
-            </a:r>
-            <a:endParaRPr lang="en-US" sz="4300" dirty="0"/>
-          </a:p>
-        </p:txBody>
-      </p:sp>
-    </p:spTree>
-    <p:extLst>
-      <p:ext uri="{BB962C8B-B14F-4D97-AF65-F5344CB8AC3E}">
-        <p14:creationId xmlns:p14="http://schemas.microsoft.com/office/powerpoint/2010/main" val="3963613558"/>
-      </p:ext>
-    </p:extLst>
-  </p:cSld>
-  <p:clrMapOvr>
-    <a:masterClrMapping/>
-  </p:clrMapOvr>
-</p:sld>
-</file>
-
-<file path=ppt/slides/slide14.xml><?xml version="1.0" encoding="utf-8"?>
-<p:sld xmlns:a="http://schemas.openxmlformats.org/drawingml/2006/main" xmlns:r="http://schemas.openxmlformats.org/officeDocument/2006/relationships" xmlns:p="http://schemas.openxmlformats.org/presentationml/2006/main">
-  <p:cSld>
-    <p:spTree>
-      <p:nvGrpSpPr>
-        <p:cNvPr id="1" name="">
-          <a:extLst>
-            <a:ext uri="{FF2B5EF4-FFF2-40B4-BE49-F238E27FC236}">
-              <a16:creationId xmlns:a16="http://schemas.microsoft.com/office/drawing/2014/main" id="{A254246C-7BF4-ACFD-34C9-9B330CC9EA17}"/>
-            </a:ext>
-          </a:extLst>
-        </p:cNvPr>
-        <p:cNvGrpSpPr/>
-        <p:nvPr/>
-      </p:nvGrpSpPr>
-      <p:grpSpPr>
-        <a:xfrm>
-          <a:off x="0" y="0"/>
-          <a:ext cx="0" cy="0"/>
-          <a:chOff x="0" y="0"/>
-          <a:chExt cx="0" cy="0"/>
-        </a:xfrm>
-      </p:grpSpPr>
-      <p:sp>
-        <p:nvSpPr>
-          <p:cNvPr id="7" name="object 7">
-            <a:extLst>
-              <a:ext uri="{FF2B5EF4-FFF2-40B4-BE49-F238E27FC236}">
-                <a16:creationId xmlns:a16="http://schemas.microsoft.com/office/drawing/2014/main" id="{E92071A6-4E29-5A2D-54B8-B31318AD2D00}"/>
-              </a:ext>
-            </a:extLst>
-          </p:cNvPr>
-          <p:cNvSpPr txBox="1">
-            <a:spLocks noGrp="1"/>
-          </p:cNvSpPr>
-          <p:nvPr>
-            <p:ph type="title"/>
-          </p:nvPr>
-        </p:nvSpPr>
-        <p:spPr>
-          <a:xfrm>
-            <a:off x="1016020" y="986508"/>
-            <a:ext cx="16255959" cy="561692"/>
-          </a:xfrm>
-          <a:prstGeom prst="rect">
-            <a:avLst/>
-          </a:prstGeom>
-        </p:spPr>
-        <p:txBody>
-          <a:bodyPr vert="horz" wrap="square" lIns="0" tIns="15875" rIns="0" bIns="0" rtlCol="0">
-            <a:spAutoFit/>
-          </a:bodyPr>
-          <a:lstStyle/>
-          <a:p>
-            <a:pPr marL="12700">
-              <a:lnSpc>
-                <a:spcPts val="4105"/>
-              </a:lnSpc>
-              <a:spcBef>
-                <a:spcPts val="125"/>
-              </a:spcBef>
-            </a:pPr>
-            <a:r>
-              <a:rPr lang="en-US" sz="3600" b="0" u="heavy" spc="-25" dirty="0">
-                <a:solidFill>
-                  <a:srgbClr val="000000"/>
-                </a:solidFill>
-                <a:uFill>
-                  <a:solidFill>
-                    <a:srgbClr val="000000"/>
-                  </a:solidFill>
-                </a:uFill>
-                <a:latin typeface="Lucida Sans Unicode"/>
-                <a:cs typeface="Lucida Sans Unicode"/>
-              </a:rPr>
-              <a:t>What’s to be Done?</a:t>
-            </a:r>
-            <a:endParaRPr sz="4300" dirty="0"/>
-          </a:p>
-        </p:txBody>
-      </p:sp>
-      <p:sp>
-        <p:nvSpPr>
-          <p:cNvPr id="8" name="object 8">
-            <a:extLst>
-              <a:ext uri="{FF2B5EF4-FFF2-40B4-BE49-F238E27FC236}">
-                <a16:creationId xmlns:a16="http://schemas.microsoft.com/office/drawing/2014/main" id="{4C5C86A8-64AD-B75D-08B3-348233585C78}"/>
-              </a:ext>
-            </a:extLst>
-          </p:cNvPr>
-          <p:cNvSpPr txBox="1"/>
-          <p:nvPr/>
-        </p:nvSpPr>
-        <p:spPr>
-          <a:xfrm>
-            <a:off x="1021882" y="1790700"/>
-            <a:ext cx="9569918" cy="1735347"/>
-          </a:xfrm>
-          <a:prstGeom prst="rect">
-            <a:avLst/>
-          </a:prstGeom>
-        </p:spPr>
-        <p:txBody>
-          <a:bodyPr vert="horz" wrap="square" lIns="0" tIns="12700" rIns="0" bIns="0" rtlCol="0">
-            <a:spAutoFit/>
-          </a:bodyPr>
-          <a:lstStyle/>
-          <a:p>
-            <a:pPr marL="355600" marR="5080" indent="-342900">
-              <a:lnSpc>
-                <a:spcPct val="113599"/>
-              </a:lnSpc>
-              <a:spcBef>
-                <a:spcPts val="100"/>
-              </a:spcBef>
-              <a:buFont typeface="Wingdings" panose="05000000000000000000" pitchFamily="2" charset="2"/>
-              <a:buChar char="§"/>
-            </a:pPr>
-            <a:r>
-              <a:rPr lang="en-US" sz="2400" dirty="0">
-                <a:latin typeface="Lucida Sans Unicode"/>
-                <a:cs typeface="Lucida Sans Unicode"/>
-              </a:rPr>
-              <a:t>Tag-based organization</a:t>
-            </a:r>
-          </a:p>
-          <a:p>
-            <a:pPr marL="355600" marR="5080" indent="-342900">
-              <a:lnSpc>
-                <a:spcPct val="113599"/>
-              </a:lnSpc>
-              <a:spcBef>
-                <a:spcPts val="100"/>
-              </a:spcBef>
-              <a:buFont typeface="Wingdings" panose="05000000000000000000" pitchFamily="2" charset="2"/>
-              <a:buChar char="§"/>
-            </a:pPr>
-            <a:r>
-              <a:rPr lang="en-US" sz="2400" dirty="0">
-                <a:latin typeface="Lucida Sans Unicode"/>
-                <a:cs typeface="Lucida Sans Unicode"/>
-              </a:rPr>
-              <a:t>AI-assisted summarization</a:t>
-            </a:r>
-          </a:p>
-          <a:p>
-            <a:pPr marL="355600" marR="5080" indent="-342900">
-              <a:lnSpc>
-                <a:spcPct val="113599"/>
-              </a:lnSpc>
-              <a:spcBef>
-                <a:spcPts val="100"/>
-              </a:spcBef>
-              <a:buFont typeface="Wingdings" panose="05000000000000000000" pitchFamily="2" charset="2"/>
-              <a:buChar char="§"/>
-            </a:pPr>
-            <a:r>
-              <a:rPr lang="en-US" sz="2400" dirty="0">
-                <a:latin typeface="Lucida Sans Unicode"/>
-                <a:cs typeface="Lucida Sans Unicode"/>
-              </a:rPr>
-              <a:t>External source integration</a:t>
-            </a:r>
-          </a:p>
-          <a:p>
-            <a:pPr marL="355600" marR="5080" indent="-342900">
-              <a:lnSpc>
-                <a:spcPct val="113599"/>
-              </a:lnSpc>
-              <a:spcBef>
-                <a:spcPts val="100"/>
-              </a:spcBef>
-              <a:buFont typeface="Wingdings" panose="05000000000000000000" pitchFamily="2" charset="2"/>
-              <a:buChar char="§"/>
-            </a:pPr>
-            <a:r>
-              <a:rPr lang="en-US" sz="2400" dirty="0">
-                <a:latin typeface="Lucida Sans Unicode"/>
-                <a:cs typeface="Lucida Sans Unicode"/>
-              </a:rPr>
-              <a:t>Rest of the frontend pages</a:t>
-            </a:r>
-          </a:p>
-        </p:txBody>
-      </p:sp>
-      <p:sp>
-        <p:nvSpPr>
-          <p:cNvPr id="9" name="object 2">
-            <a:extLst>
-              <a:ext uri="{FF2B5EF4-FFF2-40B4-BE49-F238E27FC236}">
-                <a16:creationId xmlns:a16="http://schemas.microsoft.com/office/drawing/2014/main" id="{30CEB67E-6D3D-AC30-CADB-3DE312EEBFCF}"/>
-              </a:ext>
-            </a:extLst>
-          </p:cNvPr>
-          <p:cNvSpPr/>
-          <p:nvPr/>
-        </p:nvSpPr>
-        <p:spPr>
-          <a:xfrm>
-            <a:off x="15201900" y="0"/>
-            <a:ext cx="3086100" cy="10283190"/>
-          </a:xfrm>
-          <a:custGeom>
-            <a:avLst/>
-            <a:gdLst/>
-            <a:ahLst/>
-            <a:cxnLst/>
-            <a:rect l="l" t="t" r="r" b="b"/>
-            <a:pathLst>
-              <a:path w="3086100" h="10283190">
-                <a:moveTo>
-                  <a:pt x="3086099" y="10282980"/>
-                </a:moveTo>
-                <a:lnTo>
-                  <a:pt x="0" y="10282980"/>
-                </a:lnTo>
-                <a:lnTo>
-                  <a:pt x="0" y="0"/>
-                </a:lnTo>
-                <a:lnTo>
-                  <a:pt x="3086099" y="0"/>
-                </a:lnTo>
-                <a:lnTo>
-                  <a:pt x="3086099" y="10282980"/>
-                </a:lnTo>
-                <a:close/>
-              </a:path>
-            </a:pathLst>
-          </a:custGeom>
-          <a:solidFill>
-            <a:srgbClr val="583C8F"/>
-          </a:solidFill>
-        </p:spPr>
-        <p:txBody>
-          <a:bodyPr wrap="square" lIns="0" tIns="0" rIns="0" bIns="0" rtlCol="0"/>
-          <a:lstStyle/>
-          <a:p>
-            <a:endParaRPr/>
-          </a:p>
-        </p:txBody>
-      </p:sp>
-    </p:spTree>
-    <p:extLst>
-      <p:ext uri="{BB962C8B-B14F-4D97-AF65-F5344CB8AC3E}">
-        <p14:creationId xmlns:p14="http://schemas.microsoft.com/office/powerpoint/2010/main" val="865536028"/>
-      </p:ext>
-    </p:extLst>
-  </p:cSld>
-  <p:clrMapOvr>
-    <a:masterClrMapping/>
-  </p:clrMapOvr>
-</p:sld>
-</file>
-
-<file path=ppt/slides/slide15.xml><?xml version="1.0" encoding="utf-8"?>
-<p:sld xmlns:a="http://schemas.openxmlformats.org/drawingml/2006/main" xmlns:r="http://schemas.openxmlformats.org/officeDocument/2006/relationships" xmlns:p="http://schemas.openxmlformats.org/presentationml/2006/main">
-  <p:cSld>
-    <p:spTree>
-      <p:nvGrpSpPr>
-        <p:cNvPr id="1" name="">
-          <a:extLst>
-            <a:ext uri="{FF2B5EF4-FFF2-40B4-BE49-F238E27FC236}">
               <a16:creationId xmlns:a16="http://schemas.microsoft.com/office/drawing/2014/main" id="{BFB2A294-23B9-C4BF-80B6-279032D0D5C4}"/>
             </a:ext>
           </a:extLst>
@@ -6537,7 +5814,7 @@
 </p:sld>
 </file>
 
-<file path=ppt/slides/slide16.xml><?xml version="1.0" encoding="utf-8"?>
+<file path=ppt/slides/slide14.xml><?xml version="1.0" encoding="utf-8"?>
 <p:sld xmlns:a="http://schemas.openxmlformats.org/drawingml/2006/main" xmlns:r="http://schemas.openxmlformats.org/officeDocument/2006/relationships" xmlns:p="http://schemas.openxmlformats.org/presentationml/2006/main" showMasterSp="0">
   <p:cSld>
     <p:spTree>
@@ -9419,7 +8696,7 @@
         <p:spPr>
           <a:xfrm>
             <a:off x="1021882" y="3589158"/>
-            <a:ext cx="9569918" cy="3036857"/>
+            <a:ext cx="9569918" cy="3470694"/>
           </a:xfrm>
           <a:prstGeom prst="rect">
             <a:avLst/>
@@ -9568,6 +8845,25 @@
                 <a:cs typeface="Lucida Sans Unicode"/>
               </a:rPr>
               <a:t>Forking (get a copy of a public note)</a:t>
+            </a:r>
+          </a:p>
+          <a:p>
+            <a:pPr marL="355600" marR="5080" indent="-342900">
+              <a:lnSpc>
+                <a:spcPct val="113599"/>
+              </a:lnSpc>
+              <a:spcBef>
+                <a:spcPts val="100"/>
+              </a:spcBef>
+              <a:buFont typeface="Wingdings" panose="05000000000000000000" pitchFamily="2" charset="2"/>
+              <a:buChar char="§"/>
+            </a:pPr>
+            <a:r>
+              <a:rPr lang="en-US" sz="2400" dirty="0">
+                <a:latin typeface="Lucida Sans Unicode"/>
+                <a:cs typeface="Lucida Sans Unicode"/>
+              </a:rPr>
+              <a:t>Tags based sorting and searching of public notes</a:t>
             </a:r>
           </a:p>
         </p:txBody>

</xml_diff>